<commit_message>
Added the Final ppt and Documents
</commit_message>
<xml_diff>
--- a/ppt/Vishwakarma Awards 2026-27 Stage 2 Submission PPT.pptx
+++ b/ppt/Vishwakarma Awards 2026-27 Stage 2 Submission PPT.pptx
@@ -13764,51 +13764,6 @@
           </a:p>
         </p:txBody>
       </p:sp>
-      <p:pic>
-        <p:nvPicPr>
-          <p:cNvPr id="14" name="Picture 13">
-            <a:extLst>
-              <a:ext uri="{FF2B5EF4-FFF2-40B4-BE49-F238E27FC236}">
-                <a16:creationId xmlns:a16="http://schemas.microsoft.com/office/drawing/2014/main" id="{3E158ED3-D279-8CBC-5B82-D33D9B245DB7}"/>
-              </a:ext>
-            </a:extLst>
-          </p:cNvPr>
-          <p:cNvPicPr>
-            <a:picLocks noChangeAspect="1"/>
-          </p:cNvPicPr>
-          <p:nvPr/>
-        </p:nvPicPr>
-        <p:blipFill>
-          <a:blip r:embed="rId4"/>
-          <a:srcRect t="5325" b="5325"/>
-          <a:stretch>
-            <a:fillRect/>
-          </a:stretch>
-        </p:blipFill>
-        <p:spPr>
-          <a:xfrm>
-            <a:off x="534676" y="1668772"/>
-            <a:ext cx="5705495" cy="3823371"/>
-          </a:xfrm>
-          <a:prstGeom prst="rect">
-            <a:avLst/>
-          </a:prstGeom>
-          <a:ln w="38100" cap="sq">
-            <a:solidFill>
-              <a:srgbClr val="000000"/>
-            </a:solidFill>
-            <a:prstDash val="solid"/>
-            <a:miter lim="800000"/>
-          </a:ln>
-          <a:effectLst>
-            <a:outerShdw blurRad="50800" dist="38100" dir="2700000" algn="tl" rotWithShape="0">
-              <a:srgbClr val="000000">
-                <a:alpha val="43000"/>
-              </a:srgbClr>
-            </a:outerShdw>
-          </a:effectLst>
-        </p:spPr>
-      </p:pic>
       <p:sp>
         <p:nvSpPr>
           <p:cNvPr id="15" name="TextBox 6">
@@ -13823,8 +13778,8 @@
         </p:nvSpPr>
         <p:spPr>
           <a:xfrm>
-            <a:off x="534676" y="5609983"/>
-            <a:ext cx="5714288" cy="203133"/>
+            <a:off x="963885" y="5696161"/>
+            <a:ext cx="5714288" cy="233910"/>
           </a:xfrm>
           <a:prstGeom prst="rect">
             <a:avLst/>
@@ -13937,14 +13892,14 @@
               </a:spcAft>
             </a:pPr>
             <a:r>
-              <a:rPr lang="en-US" sz="1200" b="0" dirty="0">
+              <a:rPr lang="en-US" sz="1400" b="1" dirty="0">
                 <a:latin typeface="Times New Roman" panose="02020603050405020304" pitchFamily="18" charset="0"/>
                 <a:cs typeface="Times New Roman" panose="02020603050405020304" pitchFamily="18" charset="0"/>
               </a:rPr>
               <a:t>Figure: </a:t>
             </a:r>
             <a:r>
-              <a:rPr sz="1200" b="0" dirty="0">
+              <a:rPr sz="1400" b="0" dirty="0">
                 <a:latin typeface="Times New Roman" panose="02020603050405020304" pitchFamily="18" charset="0"/>
                 <a:cs typeface="Times New Roman" panose="02020603050405020304" pitchFamily="18" charset="0"/>
               </a:rPr>
@@ -13967,8 +13922,8 @@
         </p:nvSpPr>
         <p:spPr>
           <a:xfrm>
-            <a:off x="6542280" y="1585632"/>
-            <a:ext cx="5449824" cy="4160520"/>
+            <a:off x="7318619" y="1652596"/>
+            <a:ext cx="4680916" cy="4160520"/>
           </a:xfrm>
           <a:prstGeom prst="roundRect">
             <a:avLst/>
@@ -14116,7 +14071,7 @@
         </p:nvSpPr>
         <p:spPr>
           <a:xfrm>
-            <a:off x="7533583" y="1804121"/>
+            <a:off x="7925468" y="1727201"/>
             <a:ext cx="3662895" cy="634020"/>
           </a:xfrm>
           <a:prstGeom prst="rect">
@@ -14264,7 +14219,7 @@
         </p:nvSpPr>
         <p:spPr>
           <a:xfrm>
-            <a:off x="8020733" y="2645765"/>
+            <a:off x="8412618" y="2568845"/>
             <a:ext cx="4663440" cy="233910"/>
           </a:xfrm>
           <a:prstGeom prst="rect">
@@ -14403,7 +14358,7 @@
         </p:nvSpPr>
         <p:spPr>
           <a:xfrm>
-            <a:off x="7686903" y="2934511"/>
+            <a:off x="8078788" y="2857591"/>
             <a:ext cx="3356256" cy="387798"/>
           </a:xfrm>
           <a:prstGeom prst="rect">
@@ -14540,7 +14495,7 @@
         </p:nvSpPr>
         <p:spPr>
           <a:xfrm>
-            <a:off x="8020733" y="3431982"/>
+            <a:off x="8412618" y="3355062"/>
             <a:ext cx="4663440" cy="233910"/>
           </a:xfrm>
           <a:prstGeom prst="rect">
@@ -14679,7 +14634,7 @@
         </p:nvSpPr>
         <p:spPr>
           <a:xfrm>
-            <a:off x="7589064" y="3677852"/>
+            <a:off x="7980949" y="3600932"/>
             <a:ext cx="3356256" cy="387798"/>
           </a:xfrm>
           <a:prstGeom prst="rect">
@@ -14837,7 +14792,7 @@
         </p:nvSpPr>
         <p:spPr>
           <a:xfrm>
-            <a:off x="8020733" y="4273036"/>
+            <a:off x="8412618" y="4196116"/>
             <a:ext cx="4663440" cy="233910"/>
           </a:xfrm>
           <a:prstGeom prst="rect">
@@ -14976,7 +14931,7 @@
         </p:nvSpPr>
         <p:spPr>
           <a:xfrm>
-            <a:off x="7831528" y="4518906"/>
+            <a:off x="8223413" y="4441986"/>
             <a:ext cx="3067007" cy="387798"/>
           </a:xfrm>
           <a:prstGeom prst="rect">
@@ -15113,7 +15068,7 @@
         </p:nvSpPr>
         <p:spPr>
           <a:xfrm>
-            <a:off x="7831529" y="5082936"/>
+            <a:off x="8223414" y="5006016"/>
             <a:ext cx="4663440" cy="233910"/>
           </a:xfrm>
           <a:prstGeom prst="rect">
@@ -15252,7 +15207,7 @@
         </p:nvSpPr>
         <p:spPr>
           <a:xfrm>
-            <a:off x="7311188" y="5299105"/>
+            <a:off x="7703073" y="5222185"/>
             <a:ext cx="3912008" cy="387798"/>
           </a:xfrm>
           <a:prstGeom prst="rect">
@@ -15375,6 +15330,46 @@
           </a:p>
         </p:txBody>
       </p:sp>
+      <p:pic>
+        <p:nvPicPr>
+          <p:cNvPr id="3" name="Picture 2">
+            <a:extLst>
+              <a:ext uri="{FF2B5EF4-FFF2-40B4-BE49-F238E27FC236}">
+                <a16:creationId xmlns:a16="http://schemas.microsoft.com/office/drawing/2014/main" id="{B9D67586-F971-CD91-1C39-40D5CCFE6542}"/>
+              </a:ext>
+            </a:extLst>
+          </p:cNvPr>
+          <p:cNvPicPr>
+            <a:picLocks noChangeAspect="1"/>
+          </p:cNvPicPr>
+          <p:nvPr/>
+        </p:nvPicPr>
+        <p:blipFill>
+          <a:blip r:embed="rId4"/>
+          <a:stretch>
+            <a:fillRect/>
+          </a:stretch>
+        </p:blipFill>
+        <p:spPr>
+          <a:xfrm>
+            <a:off x="552171" y="1662985"/>
+            <a:ext cx="6506278" cy="3875894"/>
+          </a:xfrm>
+          <a:prstGeom prst="rect">
+            <a:avLst/>
+          </a:prstGeom>
+          <a:ln>
+            <a:noFill/>
+          </a:ln>
+          <a:effectLst>
+            <a:outerShdw blurRad="292100" dist="139700" dir="2700000" algn="tl" rotWithShape="0">
+              <a:srgbClr val="333333">
+                <a:alpha val="65000"/>
+              </a:srgbClr>
+            </a:outerShdw>
+          </a:effectLst>
+        </p:spPr>
+      </p:pic>
     </p:spTree>
     <p:extLst>
       <p:ext uri="{BB962C8B-B14F-4D97-AF65-F5344CB8AC3E}">
@@ -15858,54 +15853,84 @@
             <a:r>
               <a:rPr b="1" dirty="0">
                 <a:solidFill>
-                  <a:srgbClr val="0070C0"/>
+                  <a:srgbClr val="0000FF"/>
                 </a:solidFill>
                 <a:latin typeface="Times New Roman" panose="02020603050405020304" pitchFamily="18" charset="0"/>
                 <a:cs typeface="Times New Roman" panose="02020603050405020304" pitchFamily="18" charset="0"/>
-                <a:hlinkClick r:id="rId2"/>
+                <a:hlinkClick r:id="rId2">
+                  <a:extLst>
+                    <a:ext uri="{A12FA001-AC4F-418D-AE19-62706E023703}">
+                      <ahyp:hlinkClr xmlns:ahyp="http://schemas.microsoft.com/office/drawing/2018/hyperlinkcolor" val="tx"/>
+                    </a:ext>
+                  </a:extLst>
+                </a:hlinkClick>
               </a:rPr>
               <a:t>github.com/</a:t>
             </a:r>
             <a:r>
               <a:rPr b="1" dirty="0" err="1">
                 <a:solidFill>
-                  <a:srgbClr val="0070C0"/>
+                  <a:srgbClr val="0000FF"/>
                 </a:solidFill>
                 <a:latin typeface="Times New Roman" panose="02020603050405020304" pitchFamily="18" charset="0"/>
                 <a:cs typeface="Times New Roman" panose="02020603050405020304" pitchFamily="18" charset="0"/>
-                <a:hlinkClick r:id="rId2"/>
+                <a:hlinkClick r:id="rId2">
+                  <a:extLst>
+                    <a:ext uri="{A12FA001-AC4F-418D-AE19-62706E023703}">
+                      <ahyp:hlinkClr xmlns:ahyp="http://schemas.microsoft.com/office/drawing/2018/hyperlinkcolor" val="tx"/>
+                    </a:ext>
+                  </a:extLst>
+                </a:hlinkClick>
               </a:rPr>
               <a:t>ConquerToFreedom</a:t>
             </a:r>
             <a:r>
               <a:rPr b="1" dirty="0">
                 <a:solidFill>
-                  <a:srgbClr val="0070C0"/>
+                  <a:srgbClr val="0000FF"/>
                 </a:solidFill>
                 <a:latin typeface="Times New Roman" panose="02020603050405020304" pitchFamily="18" charset="0"/>
                 <a:cs typeface="Times New Roman" panose="02020603050405020304" pitchFamily="18" charset="0"/>
-                <a:hlinkClick r:id="rId2"/>
+                <a:hlinkClick r:id="rId2">
+                  <a:extLst>
+                    <a:ext uri="{A12FA001-AC4F-418D-AE19-62706E023703}">
+                      <ahyp:hlinkClr xmlns:ahyp="http://schemas.microsoft.com/office/drawing/2018/hyperlinkcolor" val="tx"/>
+                    </a:ext>
+                  </a:extLst>
+                </a:hlinkClick>
               </a:rPr>
               <a:t>/</a:t>
             </a:r>
             <a:r>
               <a:rPr b="1" dirty="0" err="1">
                 <a:solidFill>
-                  <a:srgbClr val="0070C0"/>
+                  <a:srgbClr val="0000FF"/>
                 </a:solidFill>
                 <a:latin typeface="Times New Roman" panose="02020603050405020304" pitchFamily="18" charset="0"/>
                 <a:cs typeface="Times New Roman" panose="02020603050405020304" pitchFamily="18" charset="0"/>
-                <a:hlinkClick r:id="rId2"/>
+                <a:hlinkClick r:id="rId2">
+                  <a:extLst>
+                    <a:ext uri="{A12FA001-AC4F-418D-AE19-62706E023703}">
+                      <ahyp:hlinkClr xmlns:ahyp="http://schemas.microsoft.com/office/drawing/2018/hyperlinkcolor" val="tx"/>
+                    </a:ext>
+                  </a:extLst>
+                </a:hlinkClick>
               </a:rPr>
               <a:t>SwasthEdge</a:t>
             </a:r>
             <a:endParaRPr b="1" dirty="0">
               <a:solidFill>
-                <a:srgbClr val="0070C0"/>
+                <a:srgbClr val="0000FF"/>
               </a:solidFill>
               <a:latin typeface="Times New Roman" panose="02020603050405020304" pitchFamily="18" charset="0"/>
               <a:cs typeface="Times New Roman" panose="02020603050405020304" pitchFamily="18" charset="0"/>
-              <a:hlinkClick r:id="rId2"/>
+              <a:hlinkClick r:id="rId2">
+                <a:extLst>
+                  <a:ext uri="{A12FA001-AC4F-418D-AE19-62706E023703}">
+                    <ahyp:hlinkClr xmlns:ahyp="http://schemas.microsoft.com/office/drawing/2018/hyperlinkcolor" val="tx"/>
+                  </a:ext>
+                </a:extLst>
+              </a:hlinkClick>
             </a:endParaRPr>
           </a:p>
         </p:txBody>
@@ -16049,36 +16074,6 @@
       </p:sp>
       <p:pic>
         <p:nvPicPr>
-          <p:cNvPr id="29" name="Picture 28">
-            <a:extLst>
-              <a:ext uri="{FF2B5EF4-FFF2-40B4-BE49-F238E27FC236}">
-                <a16:creationId xmlns:a16="http://schemas.microsoft.com/office/drawing/2014/main" id="{3256217E-6327-9DC6-5DBD-512E551AAC38}"/>
-              </a:ext>
-            </a:extLst>
-          </p:cNvPr>
-          <p:cNvPicPr>
-            <a:picLocks noChangeAspect="1"/>
-          </p:cNvPicPr>
-          <p:nvPr/>
-        </p:nvPicPr>
-        <p:blipFill>
-          <a:blip r:embed="rId3"/>
-          <a:stretch>
-            <a:fillRect/>
-          </a:stretch>
-        </p:blipFill>
-        <p:spPr>
-          <a:xfrm>
-            <a:off x="1896219" y="1079762"/>
-            <a:ext cx="8399561" cy="4337801"/>
-          </a:xfrm>
-          <a:prstGeom prst="rect">
-            <a:avLst/>
-          </a:prstGeom>
-        </p:spPr>
-      </p:pic>
-      <p:pic>
-        <p:nvPicPr>
           <p:cNvPr id="33" name="Google Shape;343;p23" descr="image.png">
             <a:extLst>
               <a:ext uri="{FF2B5EF4-FFF2-40B4-BE49-F238E27FC236}">
@@ -16090,7 +16085,7 @@
           <p:nvPr/>
         </p:nvPicPr>
         <p:blipFill rotWithShape="1">
-          <a:blip r:embed="rId4">
+          <a:blip r:embed="rId3">
             <a:alphaModFix/>
           </a:blip>
           <a:srcRect/>
@@ -16175,8 +16170,8 @@
         </p:nvSpPr>
         <p:spPr>
           <a:xfrm>
-            <a:off x="4758177" y="5398416"/>
-            <a:ext cx="6260840" cy="276999"/>
+            <a:off x="4758177" y="5423889"/>
+            <a:ext cx="6260840" cy="338554"/>
           </a:xfrm>
           <a:prstGeom prst="rect">
             <a:avLst/>
@@ -16190,9 +16185,12 @@
           <a:lstStyle/>
           <a:p>
             <a:r>
-              <a:rPr lang="en-US" sz="1200" i="0" u="none" strike="noStrike" cap="none" dirty="0">
-                <a:solidFill>
-                  <a:schemeClr val="tx1"/>
+              <a:rPr lang="en-US" sz="1600" i="0" u="none" strike="noStrike" cap="none" dirty="0">
+                <a:solidFill>
+                  <a:schemeClr val="tx1">
+                    <a:lumMod val="95000"/>
+                    <a:lumOff val="5000"/>
+                  </a:schemeClr>
                 </a:solidFill>
                 <a:latin typeface="Times New Roman" panose="02020603050405020304" pitchFamily="18" charset="0"/>
                 <a:ea typeface="Inter"/>
@@ -16202,9 +16200,12 @@
               <a:t>Figure - EDA layout software (</a:t>
             </a:r>
             <a:r>
-              <a:rPr lang="en-US" sz="1200" i="0" u="none" strike="noStrike" cap="none" dirty="0" err="1">
-                <a:solidFill>
-                  <a:schemeClr val="tx1"/>
+              <a:rPr lang="en-US" sz="1600" i="0" u="none" strike="noStrike" cap="none" dirty="0" err="1">
+                <a:solidFill>
+                  <a:schemeClr val="tx1">
+                    <a:lumMod val="95000"/>
+                    <a:lumOff val="5000"/>
+                  </a:schemeClr>
                 </a:solidFill>
                 <a:latin typeface="Times New Roman" panose="02020603050405020304" pitchFamily="18" charset="0"/>
                 <a:ea typeface="Inter"/>
@@ -16214,9 +16215,12 @@
               <a:t>KiCad</a:t>
             </a:r>
             <a:r>
-              <a:rPr lang="en-US" sz="1200" i="0" u="none" strike="noStrike" cap="none" dirty="0">
-                <a:solidFill>
-                  <a:schemeClr val="tx1"/>
+              <a:rPr lang="en-US" sz="1600" i="0" u="none" strike="noStrike" cap="none" dirty="0">
+                <a:solidFill>
+                  <a:schemeClr val="tx1">
+                    <a:lumMod val="95000"/>
+                    <a:lumOff val="5000"/>
+                  </a:schemeClr>
                 </a:solidFill>
                 <a:latin typeface="Times New Roman" panose="02020603050405020304" pitchFamily="18" charset="0"/>
                 <a:ea typeface="Inter"/>
@@ -16225,9 +16229,12 @@
               </a:rPr>
               <a:t>) </a:t>
             </a:r>
-            <a:endParaRPr lang="en-IN" dirty="0">
+            <a:endParaRPr lang="en-IN" sz="1800" dirty="0">
               <a:solidFill>
-                <a:schemeClr val="tx1"/>
+                <a:schemeClr val="tx1">
+                  <a:lumMod val="95000"/>
+                  <a:lumOff val="5000"/>
+                </a:schemeClr>
               </a:solidFill>
               <a:latin typeface="Times New Roman" panose="02020603050405020304" pitchFamily="18" charset="0"/>
               <a:cs typeface="Times New Roman" panose="02020603050405020304" pitchFamily="18" charset="0"/>
@@ -16248,7 +16255,7 @@
           <p:nvPr/>
         </p:nvPicPr>
         <p:blipFill>
-          <a:blip r:embed="rId5">
+          <a:blip r:embed="rId4">
             <a:alphaModFix/>
           </a:blip>
           <a:stretch>
@@ -16282,7 +16289,7 @@
           <p:nvPr/>
         </p:nvPicPr>
         <p:blipFill rotWithShape="1">
-          <a:blip r:embed="rId6">
+          <a:blip r:embed="rId5">
             <a:alphaModFix/>
           </a:blip>
           <a:srcRect l="14673" t="33074" r="15820" b="44466"/>
@@ -16300,6 +16307,46 @@
           <a:ln>
             <a:noFill/>
           </a:ln>
+        </p:spPr>
+      </p:pic>
+      <p:pic>
+        <p:nvPicPr>
+          <p:cNvPr id="3" name="Picture 2">
+            <a:extLst>
+              <a:ext uri="{FF2B5EF4-FFF2-40B4-BE49-F238E27FC236}">
+                <a16:creationId xmlns:a16="http://schemas.microsoft.com/office/drawing/2014/main" id="{8D777D39-F242-0BDD-F514-0FD2BFF38FAA}"/>
+              </a:ext>
+            </a:extLst>
+          </p:cNvPr>
+          <p:cNvPicPr>
+            <a:picLocks noChangeAspect="1"/>
+          </p:cNvPicPr>
+          <p:nvPr/>
+        </p:nvPicPr>
+        <p:blipFill>
+          <a:blip r:embed="rId6"/>
+          <a:stretch>
+            <a:fillRect/>
+          </a:stretch>
+        </p:blipFill>
+        <p:spPr>
+          <a:xfrm>
+            <a:off x="1570854" y="998375"/>
+            <a:ext cx="9007786" cy="4416113"/>
+          </a:xfrm>
+          <a:prstGeom prst="rect">
+            <a:avLst/>
+          </a:prstGeom>
+          <a:ln>
+            <a:noFill/>
+          </a:ln>
+          <a:effectLst>
+            <a:outerShdw blurRad="292100" dist="139700" dir="2700000" algn="tl" rotWithShape="0">
+              <a:srgbClr val="333333">
+                <a:alpha val="65000"/>
+              </a:srgbClr>
+            </a:outerShdw>
+          </a:effectLst>
         </p:spPr>
       </p:pic>
     </p:spTree>
@@ -16739,7 +16786,7 @@
                 <a:latin typeface="Times New Roman" panose="02020603050405020304" pitchFamily="18" charset="0"/>
                 <a:cs typeface="Times New Roman" panose="02020603050405020304" pitchFamily="18" charset="0"/>
               </a:rPr>
-              <a:t>Fault Confirmation:</a:t>
+              <a:t>Fault Confirmation</a:t>
             </a:r>
             <a:br>
               <a:rPr lang="en-IN" sz="1600" dirty="0">
@@ -16773,7 +16820,7 @@
                 <a:latin typeface="Times New Roman" panose="02020603050405020304" pitchFamily="18" charset="0"/>
                 <a:cs typeface="Times New Roman" panose="02020603050405020304" pitchFamily="18" charset="0"/>
               </a:rPr>
-              <a:t>Graceful Degradation:</a:t>
+              <a:t>Graceful Degradation</a:t>
             </a:r>
             <a:br>
               <a:rPr lang="en-IN" sz="1600" dirty="0">
@@ -16807,7 +16854,7 @@
                 <a:latin typeface="Times New Roman" panose="02020603050405020304" pitchFamily="18" charset="0"/>
                 <a:cs typeface="Times New Roman" panose="02020603050405020304" pitchFamily="18" charset="0"/>
               </a:rPr>
-              <a:t>Local Fail-Critical Response:</a:t>
+              <a:t>Local Fail-Critical Response</a:t>
             </a:r>
             <a:br>
               <a:rPr lang="en-IN" sz="1600" dirty="0">
@@ -16841,7 +16888,7 @@
                 <a:latin typeface="Times New Roman" panose="02020603050405020304" pitchFamily="18" charset="0"/>
                 <a:cs typeface="Times New Roman" panose="02020603050405020304" pitchFamily="18" charset="0"/>
               </a:rPr>
-              <a:t>Fault Monitoring:</a:t>
+              <a:t>Fault Monitoring</a:t>
             </a:r>
             <a:br>
               <a:rPr lang="en-IN" sz="1600" dirty="0">
@@ -19330,7 +19377,7 @@
         </p:nvSpPr>
         <p:spPr>
           <a:xfrm>
-            <a:off x="571500" y="1532725"/>
+            <a:off x="514500" y="1187492"/>
             <a:ext cx="11049000" cy="771600"/>
           </a:xfrm>
           <a:prstGeom prst="rect">
@@ -19376,7 +19423,7 @@
         </p:nvSpPr>
         <p:spPr>
           <a:xfrm>
-            <a:off x="571500" y="2294725"/>
+            <a:off x="514500" y="1949492"/>
             <a:ext cx="11049000" cy="9600"/>
           </a:xfrm>
           <a:prstGeom prst="rect">
@@ -19424,7 +19471,7 @@
         </p:nvSpPr>
         <p:spPr>
           <a:xfrm>
-            <a:off x="571500" y="2294725"/>
+            <a:off x="514500" y="1949492"/>
             <a:ext cx="11049000" cy="9600"/>
           </a:xfrm>
           <a:prstGeom prst="rect">
@@ -19472,7 +19519,7 @@
         </p:nvSpPr>
         <p:spPr>
           <a:xfrm>
-            <a:off x="1666875" y="1682743"/>
+            <a:off x="1609875" y="1337510"/>
             <a:ext cx="9953700" cy="323165"/>
           </a:xfrm>
           <a:prstGeom prst="rect">
@@ -19503,13 +19550,25 @@
             </a:pPr>
             <a:r>
               <a:rPr lang="en-IN" dirty="0">
+                <a:solidFill>
+                  <a:srgbClr val="0000FF"/>
+                </a:solidFill>
                 <a:latin typeface="Times New Roman" panose="02020603050405020304" pitchFamily="18" charset="0"/>
                 <a:cs typeface="Times New Roman" panose="02020603050405020304" pitchFamily="18" charset="0"/>
-                <a:hlinkClick r:id="rId3"/>
+                <a:hlinkClick r:id="rId3">
+                  <a:extLst>
+                    <a:ext uri="{A12FA001-AC4F-418D-AE19-62706E023703}">
+                      <ahyp:hlinkClr xmlns:ahyp="http://schemas.microsoft.com/office/drawing/2018/hyperlinkcolor" val="tx"/>
+                    </a:ext>
+                  </a:extLst>
+                </a:hlinkClick>
               </a:rPr>
-              <a:t>https://drive.google.com/file/d/1dnByVkEYSe0oNmhWJHl_LqgME7DfzbQf/view?usp=sharing</a:t>
+              <a:t>https://drive.google.com/file/d/18aVEA84JQQvSDFFv31FtURB8URP6s71-/view?usp=sharing</a:t>
             </a:r>
             <a:endParaRPr dirty="0">
+              <a:solidFill>
+                <a:srgbClr val="0000FF"/>
+              </a:solidFill>
               <a:latin typeface="Times New Roman" panose="02020603050405020304" pitchFamily="18" charset="0"/>
               <a:cs typeface="Times New Roman" panose="02020603050405020304" pitchFamily="18" charset="0"/>
             </a:endParaRPr>
@@ -19524,7 +19583,7 @@
         </p:nvSpPr>
         <p:spPr>
           <a:xfrm>
-            <a:off x="1663457" y="1918525"/>
+            <a:off x="1606457" y="1573292"/>
             <a:ext cx="9953700" cy="276999"/>
           </a:xfrm>
           <a:prstGeom prst="rect">
@@ -19598,7 +19657,7 @@
         </p:nvSpPr>
         <p:spPr>
           <a:xfrm>
-            <a:off x="1663457" y="3390159"/>
+            <a:off x="1606457" y="3044926"/>
             <a:ext cx="9953700" cy="323165"/>
           </a:xfrm>
           <a:prstGeom prst="rect">
@@ -19642,7 +19701,7 @@
                   </a:extLst>
                 </a:hlinkClick>
               </a:rPr>
-              <a:t>https://drive.google.com/file/d/1J8Kl_8mwQmn7bzhAZe8TgKNee2rkjtv4/view?usp=sharing</a:t>
+              <a:t>https://drive.google.com/file/d/1UwEtkNEv0FDomdyTmOcfXZVLesxRijE1/view?usp=sharing</a:t>
             </a:r>
             <a:endParaRPr dirty="0">
               <a:solidFill>
@@ -19662,7 +19721,7 @@
         </p:nvSpPr>
         <p:spPr>
           <a:xfrm>
-            <a:off x="1663457" y="2774590"/>
+            <a:off x="1606457" y="2429357"/>
             <a:ext cx="9953700" cy="276999"/>
           </a:xfrm>
           <a:prstGeom prst="rect">
@@ -19872,96 +19931,6 @@
           </a:ln>
         </p:spPr>
       </p:pic>
-      <p:pic>
-        <p:nvPicPr>
-          <p:cNvPr id="3" name="Picture 2">
-            <a:extLst>
-              <a:ext uri="{FF2B5EF4-FFF2-40B4-BE49-F238E27FC236}">
-                <a16:creationId xmlns:a16="http://schemas.microsoft.com/office/drawing/2014/main" id="{77A60A10-3D3F-A919-7044-0FDA3C2D9A93}"/>
-              </a:ext>
-            </a:extLst>
-          </p:cNvPr>
-          <p:cNvPicPr>
-            <a:picLocks noChangeAspect="1"/>
-          </p:cNvPicPr>
-          <p:nvPr/>
-        </p:nvPicPr>
-        <p:blipFill>
-          <a:blip r:embed="rId8"/>
-          <a:stretch>
-            <a:fillRect/>
-          </a:stretch>
-        </p:blipFill>
-        <p:spPr>
-          <a:xfrm>
-            <a:off x="574843" y="1682743"/>
-            <a:ext cx="906587" cy="547352"/>
-          </a:xfrm>
-          <a:prstGeom prst="rect">
-            <a:avLst/>
-          </a:prstGeom>
-        </p:spPr>
-      </p:pic>
-      <p:pic>
-        <p:nvPicPr>
-          <p:cNvPr id="5" name="Picture 4">
-            <a:extLst>
-              <a:ext uri="{FF2B5EF4-FFF2-40B4-BE49-F238E27FC236}">
-                <a16:creationId xmlns:a16="http://schemas.microsoft.com/office/drawing/2014/main" id="{98EB8CA4-130C-B114-335B-D2D62CF5E68F}"/>
-              </a:ext>
-            </a:extLst>
-          </p:cNvPr>
-          <p:cNvPicPr>
-            <a:picLocks noChangeAspect="1"/>
-          </p:cNvPicPr>
-          <p:nvPr/>
-        </p:nvPicPr>
-        <p:blipFill>
-          <a:blip r:embed="rId9"/>
-          <a:stretch>
-            <a:fillRect/>
-          </a:stretch>
-        </p:blipFill>
-        <p:spPr>
-          <a:xfrm>
-            <a:off x="662473" y="3451770"/>
-            <a:ext cx="918323" cy="474251"/>
-          </a:xfrm>
-          <a:prstGeom prst="rect">
-            <a:avLst/>
-          </a:prstGeom>
-        </p:spPr>
-      </p:pic>
-      <p:pic>
-        <p:nvPicPr>
-          <p:cNvPr id="7" name="Picture 6">
-            <a:extLst>
-              <a:ext uri="{FF2B5EF4-FFF2-40B4-BE49-F238E27FC236}">
-                <a16:creationId xmlns:a16="http://schemas.microsoft.com/office/drawing/2014/main" id="{262B26E8-46BF-394F-D0AD-050D173831BB}"/>
-              </a:ext>
-            </a:extLst>
-          </p:cNvPr>
-          <p:cNvPicPr>
-            <a:picLocks noChangeAspect="1"/>
-          </p:cNvPicPr>
-          <p:nvPr/>
-        </p:nvPicPr>
-        <p:blipFill>
-          <a:blip r:embed="rId10"/>
-          <a:stretch>
-            <a:fillRect/>
-          </a:stretch>
-        </p:blipFill>
-        <p:spPr>
-          <a:xfrm>
-            <a:off x="662473" y="2490660"/>
-            <a:ext cx="818957" cy="569325"/>
-          </a:xfrm>
-          <a:prstGeom prst="rect">
-            <a:avLst/>
-          </a:prstGeom>
-        </p:spPr>
-      </p:pic>
       <p:sp>
         <p:nvSpPr>
           <p:cNvPr id="11" name="Google Shape;506;p31">
@@ -19976,7 +19945,7 @@
         </p:nvSpPr>
         <p:spPr>
           <a:xfrm>
-            <a:off x="609600" y="3193756"/>
+            <a:off x="552600" y="2848523"/>
             <a:ext cx="11049000" cy="9600"/>
           </a:xfrm>
           <a:prstGeom prst="rect">
@@ -20030,7 +19999,7 @@
         </p:nvSpPr>
         <p:spPr>
           <a:xfrm>
-            <a:off x="1663457" y="2491265"/>
+            <a:off x="1606457" y="2146032"/>
             <a:ext cx="9953700" cy="323165"/>
           </a:xfrm>
           <a:prstGeom prst="rect">
@@ -20047,17 +20016,10 @@
           </a:bodyPr>
           <a:lstStyle/>
           <a:p>
-            <a:pPr marL="0" marR="0" lvl="0" indent="0" algn="l" rtl="0">
+            <a:pPr lvl="0">
               <a:lnSpc>
                 <a:spcPct val="149948"/>
               </a:lnSpc>
-              <a:spcBef>
-                <a:spcPts val="0"/>
-              </a:spcBef>
-              <a:spcAft>
-                <a:spcPts val="0"/>
-              </a:spcAft>
-              <a:buNone/>
             </a:pPr>
             <a:r>
               <a:rPr lang="en-IN" dirty="0">
@@ -20066,7 +20028,7 @@
                 </a:solidFill>
                 <a:latin typeface="Times New Roman" panose="02020603050405020304" pitchFamily="18" charset="0"/>
                 <a:cs typeface="Times New Roman" panose="02020603050405020304" pitchFamily="18" charset="0"/>
-                <a:hlinkClick r:id="rId11">
+                <a:hlinkClick r:id="rId8">
                   <a:extLst>
                     <a:ext uri="{A12FA001-AC4F-418D-AE19-62706E023703}">
                       <ahyp:hlinkClr xmlns:ahyp="http://schemas.microsoft.com/office/drawing/2018/hyperlinkcolor" val="tx"/>
@@ -20074,7 +20036,7 @@
                   </a:extLst>
                 </a:hlinkClick>
               </a:rPr>
-              <a:t>https://drive.google.com/file/d/1kDl99OrYiaQH-MKtF4ZofFpnlcUhNGUL/view?usp=sharing</a:t>
+              <a:t>https://drive.google.com/file/d/1wYRzzO_YdnxeIhUycdN4n_Zos5l7g55y/view?usp=sharing</a:t>
             </a:r>
             <a:endParaRPr dirty="0">
               <a:solidFill>
@@ -20100,7 +20062,7 @@
         </p:nvSpPr>
         <p:spPr>
           <a:xfrm>
-            <a:off x="1580796" y="3651345"/>
+            <a:off x="1523796" y="3306112"/>
             <a:ext cx="6097554" cy="336118"/>
           </a:xfrm>
           <a:prstGeom prst="rect">
@@ -20158,6 +20120,96 @@
           </a:p>
         </p:txBody>
       </p:sp>
+      <p:pic>
+        <p:nvPicPr>
+          <p:cNvPr id="6" name="Picture 5">
+            <a:extLst>
+              <a:ext uri="{FF2B5EF4-FFF2-40B4-BE49-F238E27FC236}">
+                <a16:creationId xmlns:a16="http://schemas.microsoft.com/office/drawing/2014/main" id="{C9269D4E-3C3D-5CBE-C10F-2D9ADE76B623}"/>
+              </a:ext>
+            </a:extLst>
+          </p:cNvPr>
+          <p:cNvPicPr>
+            <a:picLocks noChangeAspect="1"/>
+          </p:cNvPicPr>
+          <p:nvPr/>
+        </p:nvPicPr>
+        <p:blipFill>
+          <a:blip r:embed="rId9"/>
+          <a:stretch>
+            <a:fillRect/>
+          </a:stretch>
+        </p:blipFill>
+        <p:spPr>
+          <a:xfrm>
+            <a:off x="494472" y="1223077"/>
+            <a:ext cx="1029324" cy="662799"/>
+          </a:xfrm>
+          <a:prstGeom prst="rect">
+            <a:avLst/>
+          </a:prstGeom>
+        </p:spPr>
+      </p:pic>
+      <p:pic>
+        <p:nvPicPr>
+          <p:cNvPr id="9" name="Picture 8">
+            <a:extLst>
+              <a:ext uri="{FF2B5EF4-FFF2-40B4-BE49-F238E27FC236}">
+                <a16:creationId xmlns:a16="http://schemas.microsoft.com/office/drawing/2014/main" id="{8473020A-CD64-E391-1DCC-23BD7ABC806F}"/>
+              </a:ext>
+            </a:extLst>
+          </p:cNvPr>
+          <p:cNvPicPr>
+            <a:picLocks noChangeAspect="1"/>
+          </p:cNvPicPr>
+          <p:nvPr/>
+        </p:nvPicPr>
+        <p:blipFill>
+          <a:blip r:embed="rId10"/>
+          <a:stretch>
+            <a:fillRect/>
+          </a:stretch>
+        </p:blipFill>
+        <p:spPr>
+          <a:xfrm>
+            <a:off x="552600" y="2078251"/>
+            <a:ext cx="971196" cy="681466"/>
+          </a:xfrm>
+          <a:prstGeom prst="rect">
+            <a:avLst/>
+          </a:prstGeom>
+        </p:spPr>
+      </p:pic>
+      <p:pic>
+        <p:nvPicPr>
+          <p:cNvPr id="13" name="Picture 12">
+            <a:extLst>
+              <a:ext uri="{FF2B5EF4-FFF2-40B4-BE49-F238E27FC236}">
+                <a16:creationId xmlns:a16="http://schemas.microsoft.com/office/drawing/2014/main" id="{0A69EFF9-3CE9-B8C2-9168-29BB21C03C34}"/>
+              </a:ext>
+            </a:extLst>
+          </p:cNvPr>
+          <p:cNvPicPr>
+            <a:picLocks noChangeAspect="1"/>
+          </p:cNvPicPr>
+          <p:nvPr/>
+        </p:nvPicPr>
+        <p:blipFill>
+          <a:blip r:embed="rId11"/>
+          <a:stretch>
+            <a:fillRect/>
+          </a:stretch>
+        </p:blipFill>
+        <p:spPr>
+          <a:xfrm>
+            <a:off x="493376" y="3033075"/>
+            <a:ext cx="1029324" cy="546073"/>
+          </a:xfrm>
+          <a:prstGeom prst="rect">
+            <a:avLst/>
+          </a:prstGeom>
+        </p:spPr>
+      </p:pic>
     </p:spTree>
   </p:cSld>
   <p:clrMapOvr>
@@ -20295,66 +20347,14 @@
       </p:sp>
       <p:sp>
         <p:nvSpPr>
-          <p:cNvPr id="536" name="Google Shape;536;p32"/>
-          <p:cNvSpPr txBox="1"/>
-          <p:nvPr/>
-        </p:nvSpPr>
-        <p:spPr>
-          <a:xfrm>
-            <a:off x="1613772" y="1150117"/>
-            <a:ext cx="10029825" cy="312393"/>
-          </a:xfrm>
-          <a:prstGeom prst="rect">
-            <a:avLst/>
-          </a:prstGeom>
-          <a:noFill/>
-          <a:ln>
-            <a:noFill/>
-          </a:ln>
-        </p:spPr>
-        <p:txBody>
-          <a:bodyPr spcFirstLastPara="1" wrap="square" lIns="0" tIns="0" rIns="0" bIns="0" anchor="t" anchorCtr="0">
-            <a:spAutoFit/>
-          </a:bodyPr>
-          <a:lstStyle/>
-          <a:p>
-            <a:pPr marL="0" marR="0" lvl="0" indent="0" algn="l" rtl="0">
-              <a:lnSpc>
-                <a:spcPct val="144923"/>
-              </a:lnSpc>
-              <a:spcBef>
-                <a:spcPts val="0"/>
-              </a:spcBef>
-              <a:spcAft>
-                <a:spcPts val="0"/>
-              </a:spcAft>
-              <a:buNone/>
-            </a:pPr>
-            <a:r>
-              <a:rPr lang="en-IN" dirty="0">
-                <a:latin typeface="Times New Roman" panose="02020603050405020304" pitchFamily="18" charset="0"/>
-                <a:cs typeface="Times New Roman" panose="02020603050405020304" pitchFamily="18" charset="0"/>
-                <a:hlinkClick r:id="rId3"/>
-              </a:rPr>
-              <a:t>https://drive.google.com/file/d/1AR_u_w9m7Jpl2TkPtHfas62wOEYsVLAI/view?usp=sharing</a:t>
-            </a:r>
-            <a:endParaRPr dirty="0">
-              <a:latin typeface="Times New Roman" panose="02020603050405020304" pitchFamily="18" charset="0"/>
-              <a:cs typeface="Times New Roman" panose="02020603050405020304" pitchFamily="18" charset="0"/>
-            </a:endParaRPr>
-          </a:p>
-        </p:txBody>
-      </p:sp>
-      <p:sp>
-        <p:nvSpPr>
           <p:cNvPr id="537" name="Google Shape;537;p32"/>
           <p:cNvSpPr txBox="1"/>
           <p:nvPr/>
         </p:nvSpPr>
         <p:spPr>
           <a:xfrm>
-            <a:off x="1628775" y="1505694"/>
-            <a:ext cx="10029825" cy="267766"/>
+            <a:off x="1651598" y="1509061"/>
+            <a:ext cx="10029825" cy="312393"/>
           </a:xfrm>
           <a:prstGeom prst="rect">
             <a:avLst/>
@@ -20383,7 +20383,7 @@
               <a:buNone/>
             </a:pPr>
             <a:r>
-              <a:rPr lang="en-US" sz="1200" b="0" i="0" u="none" strike="noStrike" cap="none" dirty="0">
+              <a:rPr lang="en-US" b="0" i="0" u="none" strike="noStrike" cap="none" dirty="0">
                 <a:solidFill>
                   <a:srgbClr val="334155"/>
                 </a:solidFill>
@@ -20395,7 +20395,7 @@
               <a:t>Source: </a:t>
             </a:r>
             <a:r>
-              <a:rPr lang="en-US" sz="1200" b="0" i="0" u="none" strike="noStrike" cap="none" dirty="0">
+              <a:rPr lang="en-US" b="0" i="0" u="none" strike="noStrike" cap="none" dirty="0">
                 <a:solidFill>
                   <a:srgbClr val="0000FF"/>
                 </a:solidFill>
@@ -20403,7 +20403,7 @@
                 <a:ea typeface="DM Sans"/>
                 <a:cs typeface="Times New Roman" panose="02020603050405020304" pitchFamily="18" charset="0"/>
                 <a:sym typeface="DM Sans"/>
-                <a:hlinkClick r:id="rId4">
+                <a:hlinkClick r:id="rId3">
                   <a:extLst>
                     <a:ext uri="{A12FA001-AC4F-418D-AE19-62706E023703}">
                       <ahyp:hlinkClr xmlns:ahyp="http://schemas.microsoft.com/office/drawing/2018/hyperlinkcolor" val="tx"/>
@@ -20413,7 +20413,7 @@
               </a:rPr>
               <a:t>drive.google.com</a:t>
             </a:r>
-            <a:endParaRPr dirty="0">
+            <a:endParaRPr sz="1600" dirty="0">
               <a:solidFill>
                 <a:srgbClr val="0000FF"/>
               </a:solidFill>
@@ -20430,7 +20430,7 @@
           <p:nvPr/>
         </p:nvPicPr>
         <p:blipFill>
-          <a:blip r:embed="rId5">
+          <a:blip r:embed="rId4">
             <a:alphaModFix/>
           </a:blip>
           <a:stretch>
@@ -20458,7 +20458,7 @@
           <p:nvPr/>
         </p:nvPicPr>
         <p:blipFill rotWithShape="1">
-          <a:blip r:embed="rId6">
+          <a:blip r:embed="rId5">
             <a:alphaModFix/>
           </a:blip>
           <a:srcRect l="14673" t="33074" r="15820" b="44466"/>
@@ -20480,10 +20480,10 @@
       </p:pic>
       <p:pic>
         <p:nvPicPr>
-          <p:cNvPr id="3" name="Picture 2">
+          <p:cNvPr id="4" name="Picture 3">
             <a:extLst>
               <a:ext uri="{FF2B5EF4-FFF2-40B4-BE49-F238E27FC236}">
-                <a16:creationId xmlns:a16="http://schemas.microsoft.com/office/drawing/2014/main" id="{BBA04B0C-654E-9E64-E418-8286C6F662C4}"/>
+                <a16:creationId xmlns:a16="http://schemas.microsoft.com/office/drawing/2014/main" id="{917855F5-9CB1-FFE7-B5A8-1EDA9D97BDCA}"/>
               </a:ext>
             </a:extLst>
           </p:cNvPr>
@@ -20493,21 +20493,76 @@
           <p:nvPr/>
         </p:nvPicPr>
         <p:blipFill>
-          <a:blip r:embed="rId7"/>
+          <a:blip r:embed="rId6"/>
           <a:stretch>
             <a:fillRect/>
           </a:stretch>
         </p:blipFill>
         <p:spPr>
           <a:xfrm>
-            <a:off x="654698" y="1099095"/>
-            <a:ext cx="852779" cy="639584"/>
+            <a:off x="492923" y="1153077"/>
+            <a:ext cx="1060200" cy="620383"/>
           </a:xfrm>
           <a:prstGeom prst="rect">
             <a:avLst/>
           </a:prstGeom>
         </p:spPr>
       </p:pic>
+      <p:sp>
+        <p:nvSpPr>
+          <p:cNvPr id="5" name="TextBox 4">
+            <a:extLst>
+              <a:ext uri="{FF2B5EF4-FFF2-40B4-BE49-F238E27FC236}">
+                <a16:creationId xmlns:a16="http://schemas.microsoft.com/office/drawing/2014/main" id="{606BDF8F-C3AB-6EDE-E956-F711E80FE09C}"/>
+              </a:ext>
+            </a:extLst>
+          </p:cNvPr>
+          <p:cNvSpPr txBox="1"/>
+          <p:nvPr/>
+        </p:nvSpPr>
+        <p:spPr>
+          <a:xfrm>
+            <a:off x="1553123" y="1234362"/>
+            <a:ext cx="9156040" cy="307777"/>
+          </a:xfrm>
+          <a:prstGeom prst="rect">
+            <a:avLst/>
+          </a:prstGeom>
+          <a:noFill/>
+        </p:spPr>
+        <p:txBody>
+          <a:bodyPr wrap="square" rtlCol="0">
+            <a:spAutoFit/>
+          </a:bodyPr>
+          <a:lstStyle/>
+          <a:p>
+            <a:r>
+              <a:rPr lang="en-IN" dirty="0">
+                <a:solidFill>
+                  <a:srgbClr val="0000FF"/>
+                </a:solidFill>
+                <a:latin typeface="Times New Roman" panose="02020603050405020304" pitchFamily="18" charset="0"/>
+                <a:cs typeface="Times New Roman" panose="02020603050405020304" pitchFamily="18" charset="0"/>
+                <a:hlinkClick r:id="rId7">
+                  <a:extLst>
+                    <a:ext uri="{A12FA001-AC4F-418D-AE19-62706E023703}">
+                      <ahyp:hlinkClr xmlns:ahyp="http://schemas.microsoft.com/office/drawing/2018/hyperlinkcolor" val="tx"/>
+                    </a:ext>
+                  </a:extLst>
+                </a:hlinkClick>
+              </a:rPr>
+              <a:t>https://drive.google.com/file/d/1MzbbyO2kHNY1_z6F4SUou90y5NS2iWfl/view?usp=drivesdk</a:t>
+            </a:r>
+            <a:endParaRPr lang="en-IN" dirty="0">
+              <a:solidFill>
+                <a:srgbClr val="0000FF"/>
+              </a:solidFill>
+              <a:latin typeface="Times New Roman" panose="02020603050405020304" pitchFamily="18" charset="0"/>
+              <a:cs typeface="Times New Roman" panose="02020603050405020304" pitchFamily="18" charset="0"/>
+            </a:endParaRPr>
+          </a:p>
+        </p:txBody>
+      </p:sp>
     </p:spTree>
   </p:cSld>
   <p:clrMapOvr>
@@ -24921,7 +24976,10 @@
             <a:r>
               <a:rPr sz="2000" b="1" dirty="0">
                 <a:solidFill>
-                  <a:schemeClr val="tx1"/>
+                  <a:schemeClr val="tx1">
+                    <a:lumMod val="65000"/>
+                    <a:lumOff val="35000"/>
+                  </a:schemeClr>
                 </a:solidFill>
                 <a:latin typeface="Times New Roman" panose="02020603050405020304" pitchFamily="18" charset="0"/>
                 <a:cs typeface="Times New Roman" panose="02020603050405020304" pitchFamily="18" charset="0"/>
@@ -29924,41 +29982,6 @@
           </a:p>
         </p:txBody>
       </p:sp>
-      <p:pic>
-        <p:nvPicPr>
-          <p:cNvPr id="49" name="Picture 48">
-            <a:extLst>
-              <a:ext uri="{FF2B5EF4-FFF2-40B4-BE49-F238E27FC236}">
-                <a16:creationId xmlns:a16="http://schemas.microsoft.com/office/drawing/2014/main" id="{F7AB4078-ADD4-5930-6A5A-8B3973E3137C}"/>
-              </a:ext>
-            </a:extLst>
-          </p:cNvPr>
-          <p:cNvPicPr>
-            <a:picLocks noChangeAspect="1"/>
-          </p:cNvPicPr>
-          <p:nvPr/>
-        </p:nvPicPr>
-        <p:blipFill>
-          <a:blip r:embed="rId4"/>
-          <a:stretch>
-            <a:fillRect/>
-          </a:stretch>
-        </p:blipFill>
-        <p:spPr>
-          <a:xfrm>
-            <a:off x="386755" y="1377936"/>
-            <a:ext cx="5478545" cy="4102127"/>
-          </a:xfrm>
-          <a:prstGeom prst="rect">
-            <a:avLst/>
-          </a:prstGeom>
-          <a:ln w="19050">
-            <a:solidFill>
-              <a:schemeClr val="tx1"/>
-            </a:solidFill>
-          </a:ln>
-        </p:spPr>
-      </p:pic>
       <p:sp>
         <p:nvSpPr>
           <p:cNvPr id="51" name="Text 1">
@@ -29973,7 +29996,7 @@
         </p:nvSpPr>
         <p:spPr>
           <a:xfrm>
-            <a:off x="2004232" y="846929"/>
+            <a:off x="2134861" y="1042680"/>
             <a:ext cx="4898821" cy="402336"/>
           </a:xfrm>
           <a:prstGeom prst="rect">
@@ -31908,6 +31931,58 @@
           </a:p>
         </p:txBody>
       </p:sp>
+      <p:pic>
+        <p:nvPicPr>
+          <p:cNvPr id="6" name="Picture 5">
+            <a:extLst>
+              <a:ext uri="{FF2B5EF4-FFF2-40B4-BE49-F238E27FC236}">
+                <a16:creationId xmlns:a16="http://schemas.microsoft.com/office/drawing/2014/main" id="{8C9CE8EC-4D7C-E67D-EEF0-74C09DFF3E1B}"/>
+              </a:ext>
+            </a:extLst>
+          </p:cNvPr>
+          <p:cNvPicPr>
+            <a:picLocks noChangeAspect="1"/>
+          </p:cNvPicPr>
+          <p:nvPr/>
+        </p:nvPicPr>
+        <p:blipFill>
+          <a:blip r:embed="rId4">
+            <a:extLst>
+              <a:ext uri="{BEBA8EAE-BF5A-486C-A8C5-ECC9F3942E4B}">
+                <a14:imgProps xmlns:a14="http://schemas.microsoft.com/office/drawing/2010/main">
+                  <a14:imgLayer r:embed="rId5">
+                    <a14:imgEffect>
+                      <a14:brightnessContrast bright="40000"/>
+                    </a14:imgEffect>
+                  </a14:imgLayer>
+                </a14:imgProps>
+              </a:ext>
+            </a:extLst>
+          </a:blip>
+          <a:stretch>
+            <a:fillRect/>
+          </a:stretch>
+        </p:blipFill>
+        <p:spPr>
+          <a:xfrm>
+            <a:off x="402970" y="1677926"/>
+            <a:ext cx="5769323" cy="3714965"/>
+          </a:xfrm>
+          <a:prstGeom prst="rect">
+            <a:avLst/>
+          </a:prstGeom>
+          <a:ln>
+            <a:noFill/>
+          </a:ln>
+          <a:effectLst>
+            <a:outerShdw blurRad="190500" algn="tl" rotWithShape="0">
+              <a:srgbClr val="000000">
+                <a:alpha val="70000"/>
+              </a:srgbClr>
+            </a:outerShdw>
+          </a:effectLst>
+        </p:spPr>
+      </p:pic>
     </p:spTree>
     <p:extLst>
       <p:ext uri="{BB962C8B-B14F-4D97-AF65-F5344CB8AC3E}">
@@ -31938,871 +32013,6 @@
           <a:chExt cx="0" cy="0"/>
         </a:xfrm>
       </p:grpSpPr>
-      <p:sp>
-        <p:nvSpPr>
-          <p:cNvPr id="5" name="schematic-image-prompt">
-            <a:extLst>
-              <a:ext uri="{FF2B5EF4-FFF2-40B4-BE49-F238E27FC236}">
-                <a16:creationId xmlns:a16="http://schemas.microsoft.com/office/drawing/2014/main" id="{39D3777A-ACB0-7965-4CAC-397A76EC7D82}"/>
-              </a:ext>
-            </a:extLst>
-          </p:cNvPr>
-          <p:cNvSpPr>
-            <a:spLocks noGrp="1"/>
-          </p:cNvSpPr>
-          <p:nvPr/>
-        </p:nvSpPr>
-        <p:spPr>
-          <a:xfrm>
-            <a:off x="1028700" y="2505971"/>
-            <a:ext cx="5581650" cy="438150"/>
-          </a:xfrm>
-          <a:prstGeom prst="rect">
-            <a:avLst/>
-          </a:prstGeom>
-          <a:noFill/>
-          <a:ln w="0">
-            <a:noFill/>
-            <a:prstDash val="solid"/>
-          </a:ln>
-        </p:spPr>
-        <p:txBody>
-          <a:bodyPr wrap="square" lIns="0" tIns="0" rIns="0" bIns="0" anchor="ctr">
-            <a:normAutofit/>
-          </a:bodyPr>
-          <a:lstStyle>
-            <a:lvl1pPr algn="ctr">
-              <a:buNone/>
-              <a:defRPr sz="1650" b="0">
-                <a:solidFill>
-                  <a:srgbClr val="8898AA"/>
-                </a:solidFill>
-                <a:latin typeface="Aptos"/>
-                <a:ea typeface="Aptos"/>
-                <a:cs typeface="Aptos"/>
-              </a:defRPr>
-            </a:lvl1pPr>
-            <a:lvl2pPr algn="ctr">
-              <a:buNone/>
-              <a:defRPr sz="1650" b="0">
-                <a:solidFill>
-                  <a:srgbClr val="8898AA"/>
-                </a:solidFill>
-                <a:latin typeface="Aptos"/>
-                <a:ea typeface="Aptos"/>
-                <a:cs typeface="Aptos"/>
-              </a:defRPr>
-            </a:lvl2pPr>
-            <a:lvl3pPr algn="ctr">
-              <a:buNone/>
-              <a:defRPr sz="1650" b="0">
-                <a:solidFill>
-                  <a:srgbClr val="8898AA"/>
-                </a:solidFill>
-                <a:latin typeface="Aptos"/>
-                <a:ea typeface="Aptos"/>
-                <a:cs typeface="Aptos"/>
-              </a:defRPr>
-            </a:lvl3pPr>
-            <a:lvl4pPr algn="ctr">
-              <a:buNone/>
-              <a:defRPr sz="1650" b="0">
-                <a:solidFill>
-                  <a:srgbClr val="8898AA"/>
-                </a:solidFill>
-                <a:latin typeface="Aptos"/>
-                <a:ea typeface="Aptos"/>
-                <a:cs typeface="Aptos"/>
-              </a:defRPr>
-            </a:lvl4pPr>
-            <a:lvl5pPr algn="ctr">
-              <a:buNone/>
-              <a:defRPr sz="1650" b="0">
-                <a:solidFill>
-                  <a:srgbClr val="8898AA"/>
-                </a:solidFill>
-                <a:latin typeface="Aptos"/>
-                <a:ea typeface="Aptos"/>
-                <a:cs typeface="Aptos"/>
-              </a:defRPr>
-            </a:lvl5pPr>
-            <a:lvl6pPr algn="ctr">
-              <a:buNone/>
-              <a:defRPr sz="1650" b="0">
-                <a:solidFill>
-                  <a:srgbClr val="8898AA"/>
-                </a:solidFill>
-                <a:latin typeface="Aptos"/>
-                <a:ea typeface="Aptos"/>
-                <a:cs typeface="Aptos"/>
-              </a:defRPr>
-            </a:lvl6pPr>
-            <a:lvl7pPr algn="ctr">
-              <a:buNone/>
-              <a:defRPr sz="1650" b="0">
-                <a:solidFill>
-                  <a:srgbClr val="8898AA"/>
-                </a:solidFill>
-                <a:latin typeface="Aptos"/>
-                <a:ea typeface="Aptos"/>
-                <a:cs typeface="Aptos"/>
-              </a:defRPr>
-            </a:lvl7pPr>
-            <a:lvl8pPr algn="ctr">
-              <a:buNone/>
-              <a:defRPr sz="1650" b="0">
-                <a:solidFill>
-                  <a:srgbClr val="8898AA"/>
-                </a:solidFill>
-                <a:latin typeface="Aptos"/>
-                <a:ea typeface="Aptos"/>
-                <a:cs typeface="Aptos"/>
-              </a:defRPr>
-            </a:lvl8pPr>
-            <a:lvl9pPr algn="ctr">
-              <a:buNone/>
-              <a:defRPr sz="1650" b="0">
-                <a:solidFill>
-                  <a:srgbClr val="8898AA"/>
-                </a:solidFill>
-                <a:latin typeface="Aptos"/>
-                <a:ea typeface="Aptos"/>
-                <a:cs typeface="Aptos"/>
-              </a:defRPr>
-            </a:lvl9pPr>
-          </a:lstStyle>
-          <a:p>
-            <a:pPr algn="ctr">
-              <a:buNone/>
-              <a:defRPr sz="1650" b="0">
-                <a:solidFill>
-                  <a:srgbClr val="8898AA"/>
-                </a:solidFill>
-                <a:latin typeface="Aptos"/>
-                <a:ea typeface="Aptos"/>
-                <a:cs typeface="Aptos"/>
-              </a:defRPr>
-            </a:pPr>
-            <a:r>
-              <a:rPr sz="1650" b="0">
-                <a:solidFill>
-                  <a:srgbClr val="8898AA"/>
-                </a:solidFill>
-                <a:latin typeface="Times New Roman" panose="02020603050405020304" pitchFamily="18" charset="0"/>
-                <a:cs typeface="Times New Roman" panose="02020603050405020304" pitchFamily="18" charset="0"/>
-              </a:rPr>
-              <a:t>Drop cropped KiCad schematic here</a:t>
-            </a:r>
-          </a:p>
-        </p:txBody>
-      </p:sp>
-      <p:sp>
-        <p:nvSpPr>
-          <p:cNvPr id="7" name="schematic-callout-1">
-            <a:extLst>
-              <a:ext uri="{FF2B5EF4-FFF2-40B4-BE49-F238E27FC236}">
-                <a16:creationId xmlns:a16="http://schemas.microsoft.com/office/drawing/2014/main" id="{7ACB8AA5-E5AF-B14A-3914-17BE7940CE09}"/>
-              </a:ext>
-            </a:extLst>
-          </p:cNvPr>
-          <p:cNvSpPr>
-            <a:spLocks noGrp="1"/>
-          </p:cNvSpPr>
-          <p:nvPr/>
-        </p:nvSpPr>
-        <p:spPr>
-          <a:xfrm>
-            <a:off x="442447" y="5061789"/>
-            <a:ext cx="2133600" cy="409575"/>
-          </a:xfrm>
-          <a:prstGeom prst="rect">
-            <a:avLst/>
-          </a:prstGeom>
-          <a:ln/>
-        </p:spPr>
-        <p:style>
-          <a:lnRef idx="1">
-            <a:schemeClr val="dk1"/>
-          </a:lnRef>
-          <a:fillRef idx="2">
-            <a:schemeClr val="dk1"/>
-          </a:fillRef>
-          <a:effectRef idx="1">
-            <a:schemeClr val="dk1"/>
-          </a:effectRef>
-          <a:fontRef idx="minor">
-            <a:schemeClr val="dk1"/>
-          </a:fontRef>
-        </p:style>
-      </p:sp>
-      <p:sp>
-        <p:nvSpPr>
-          <p:cNvPr id="9" name="schematic-callout-text-1">
-            <a:extLst>
-              <a:ext uri="{FF2B5EF4-FFF2-40B4-BE49-F238E27FC236}">
-                <a16:creationId xmlns:a16="http://schemas.microsoft.com/office/drawing/2014/main" id="{B986FA19-90E8-FFE0-AED5-5BC26DBBCE05}"/>
-              </a:ext>
-            </a:extLst>
-          </p:cNvPr>
-          <p:cNvSpPr>
-            <a:spLocks noGrp="1"/>
-          </p:cNvSpPr>
-          <p:nvPr/>
-        </p:nvSpPr>
-        <p:spPr>
-          <a:xfrm>
-            <a:off x="523946" y="5092339"/>
-            <a:ext cx="2000250" cy="361950"/>
-          </a:xfrm>
-          <a:prstGeom prst="rect">
-            <a:avLst/>
-          </a:prstGeom>
-          <a:noFill/>
-          <a:ln w="0">
-            <a:noFill/>
-            <a:prstDash val="solid"/>
-          </a:ln>
-        </p:spPr>
-        <p:txBody>
-          <a:bodyPr wrap="square" lIns="0" tIns="0" rIns="0" bIns="0" anchor="ctr">
-            <a:normAutofit/>
-          </a:bodyPr>
-          <a:lstStyle>
-            <a:lvl1pPr algn="ctr">
-              <a:buNone/>
-              <a:defRPr sz="1163" b="1">
-                <a:solidFill>
-                  <a:srgbClr val="A52A2A"/>
-                </a:solidFill>
-                <a:latin typeface="Aptos"/>
-                <a:ea typeface="Aptos"/>
-                <a:cs typeface="Aptos"/>
-              </a:defRPr>
-            </a:lvl1pPr>
-            <a:lvl2pPr algn="ctr">
-              <a:buNone/>
-              <a:defRPr sz="1163" b="1">
-                <a:solidFill>
-                  <a:srgbClr val="A52A2A"/>
-                </a:solidFill>
-                <a:latin typeface="Aptos"/>
-                <a:ea typeface="Aptos"/>
-                <a:cs typeface="Aptos"/>
-              </a:defRPr>
-            </a:lvl2pPr>
-            <a:lvl3pPr algn="ctr">
-              <a:buNone/>
-              <a:defRPr sz="1163" b="1">
-                <a:solidFill>
-                  <a:srgbClr val="A52A2A"/>
-                </a:solidFill>
-                <a:latin typeface="Aptos"/>
-                <a:ea typeface="Aptos"/>
-                <a:cs typeface="Aptos"/>
-              </a:defRPr>
-            </a:lvl3pPr>
-            <a:lvl4pPr algn="ctr">
-              <a:buNone/>
-              <a:defRPr sz="1163" b="1">
-                <a:solidFill>
-                  <a:srgbClr val="A52A2A"/>
-                </a:solidFill>
-                <a:latin typeface="Aptos"/>
-                <a:ea typeface="Aptos"/>
-                <a:cs typeface="Aptos"/>
-              </a:defRPr>
-            </a:lvl4pPr>
-            <a:lvl5pPr algn="ctr">
-              <a:buNone/>
-              <a:defRPr sz="1163" b="1">
-                <a:solidFill>
-                  <a:srgbClr val="A52A2A"/>
-                </a:solidFill>
-                <a:latin typeface="Aptos"/>
-                <a:ea typeface="Aptos"/>
-                <a:cs typeface="Aptos"/>
-              </a:defRPr>
-            </a:lvl5pPr>
-            <a:lvl6pPr algn="ctr">
-              <a:buNone/>
-              <a:defRPr sz="1163" b="1">
-                <a:solidFill>
-                  <a:srgbClr val="A52A2A"/>
-                </a:solidFill>
-                <a:latin typeface="Aptos"/>
-                <a:ea typeface="Aptos"/>
-                <a:cs typeface="Aptos"/>
-              </a:defRPr>
-            </a:lvl6pPr>
-            <a:lvl7pPr algn="ctr">
-              <a:buNone/>
-              <a:defRPr sz="1163" b="1">
-                <a:solidFill>
-                  <a:srgbClr val="A52A2A"/>
-                </a:solidFill>
-                <a:latin typeface="Aptos"/>
-                <a:ea typeface="Aptos"/>
-                <a:cs typeface="Aptos"/>
-              </a:defRPr>
-            </a:lvl7pPr>
-            <a:lvl8pPr algn="ctr">
-              <a:buNone/>
-              <a:defRPr sz="1163" b="1">
-                <a:solidFill>
-                  <a:srgbClr val="A52A2A"/>
-                </a:solidFill>
-                <a:latin typeface="Aptos"/>
-                <a:ea typeface="Aptos"/>
-                <a:cs typeface="Aptos"/>
-              </a:defRPr>
-            </a:lvl8pPr>
-            <a:lvl9pPr algn="ctr">
-              <a:buNone/>
-              <a:defRPr sz="1163" b="1">
-                <a:solidFill>
-                  <a:srgbClr val="A52A2A"/>
-                </a:solidFill>
-                <a:latin typeface="Aptos"/>
-                <a:ea typeface="Aptos"/>
-                <a:cs typeface="Aptos"/>
-              </a:defRPr>
-            </a:lvl9pPr>
-          </a:lstStyle>
-          <a:p>
-            <a:pPr algn="ctr">
-              <a:buNone/>
-              <a:defRPr sz="1163" b="1">
-                <a:solidFill>
-                  <a:srgbClr val="A52A2A"/>
-                </a:solidFill>
-                <a:latin typeface="Aptos"/>
-                <a:ea typeface="Aptos"/>
-                <a:cs typeface="Aptos"/>
-              </a:defRPr>
-            </a:pPr>
-            <a:r>
-              <a:rPr sz="1163" b="1" dirty="0">
-                <a:solidFill>
-                  <a:schemeClr val="tx1"/>
-                </a:solidFill>
-                <a:latin typeface="Times New Roman" panose="02020603050405020304" pitchFamily="18" charset="0"/>
-                <a:cs typeface="Times New Roman" panose="02020603050405020304" pitchFamily="18" charset="0"/>
-              </a:rPr>
-              <a:t>STM32F446RE</a:t>
-            </a:r>
-          </a:p>
-          <a:p>
-            <a:pPr algn="ctr">
-              <a:buNone/>
-              <a:defRPr sz="1163" b="1">
-                <a:solidFill>
-                  <a:srgbClr val="A52A2A"/>
-                </a:solidFill>
-                <a:latin typeface="Aptos"/>
-                <a:ea typeface="Aptos"/>
-                <a:cs typeface="Aptos"/>
-              </a:defRPr>
-            </a:pPr>
-            <a:r>
-              <a:rPr sz="1163" b="1" dirty="0">
-                <a:solidFill>
-                  <a:schemeClr val="tx1"/>
-                </a:solidFill>
-                <a:latin typeface="Times New Roman" panose="02020603050405020304" pitchFamily="18" charset="0"/>
-                <a:cs typeface="Times New Roman" panose="02020603050405020304" pitchFamily="18" charset="0"/>
-              </a:rPr>
-              <a:t>(Edge AI Core)</a:t>
-            </a:r>
-          </a:p>
-        </p:txBody>
-      </p:sp>
-      <p:sp>
-        <p:nvSpPr>
-          <p:cNvPr id="11" name="schematic-callout-2">
-            <a:extLst>
-              <a:ext uri="{FF2B5EF4-FFF2-40B4-BE49-F238E27FC236}">
-                <a16:creationId xmlns:a16="http://schemas.microsoft.com/office/drawing/2014/main" id="{AF438CF4-0B0F-BE13-98E0-608034F4C307}"/>
-              </a:ext>
-            </a:extLst>
-          </p:cNvPr>
-          <p:cNvSpPr>
-            <a:spLocks noGrp="1"/>
-          </p:cNvSpPr>
-          <p:nvPr/>
-        </p:nvSpPr>
-        <p:spPr>
-          <a:xfrm>
-            <a:off x="2812730" y="5078404"/>
-            <a:ext cx="2133600" cy="409575"/>
-          </a:xfrm>
-          <a:prstGeom prst="rect">
-            <a:avLst/>
-          </a:prstGeom>
-          <a:ln/>
-        </p:spPr>
-        <p:style>
-          <a:lnRef idx="1">
-            <a:schemeClr val="dk1"/>
-          </a:lnRef>
-          <a:fillRef idx="2">
-            <a:schemeClr val="dk1"/>
-          </a:fillRef>
-          <a:effectRef idx="1">
-            <a:schemeClr val="dk1"/>
-          </a:effectRef>
-          <a:fontRef idx="minor">
-            <a:schemeClr val="dk1"/>
-          </a:fontRef>
-        </p:style>
-      </p:sp>
-      <p:sp>
-        <p:nvSpPr>
-          <p:cNvPr id="13" name="schematic-callout-text-2">
-            <a:extLst>
-              <a:ext uri="{FF2B5EF4-FFF2-40B4-BE49-F238E27FC236}">
-                <a16:creationId xmlns:a16="http://schemas.microsoft.com/office/drawing/2014/main" id="{8A4D3F6E-D147-8B2F-1044-AFE3C9B8F14C}"/>
-              </a:ext>
-            </a:extLst>
-          </p:cNvPr>
-          <p:cNvSpPr>
-            <a:spLocks noGrp="1"/>
-          </p:cNvSpPr>
-          <p:nvPr/>
-        </p:nvSpPr>
-        <p:spPr>
-          <a:xfrm>
-            <a:off x="2879405" y="5085602"/>
-            <a:ext cx="2000250" cy="361950"/>
-          </a:xfrm>
-          <a:prstGeom prst="rect">
-            <a:avLst/>
-          </a:prstGeom>
-          <a:noFill/>
-          <a:ln w="0">
-            <a:noFill/>
-            <a:prstDash val="solid"/>
-          </a:ln>
-        </p:spPr>
-        <p:txBody>
-          <a:bodyPr wrap="square" lIns="0" tIns="0" rIns="0" bIns="0" anchor="ctr">
-            <a:normAutofit/>
-          </a:bodyPr>
-          <a:lstStyle>
-            <a:lvl1pPr algn="ctr">
-              <a:buNone/>
-              <a:defRPr sz="1163" b="1">
-                <a:solidFill>
-                  <a:srgbClr val="A52A2A"/>
-                </a:solidFill>
-                <a:latin typeface="Aptos"/>
-                <a:ea typeface="Aptos"/>
-                <a:cs typeface="Aptos"/>
-              </a:defRPr>
-            </a:lvl1pPr>
-            <a:lvl2pPr algn="ctr">
-              <a:buNone/>
-              <a:defRPr sz="1163" b="1">
-                <a:solidFill>
-                  <a:srgbClr val="A52A2A"/>
-                </a:solidFill>
-                <a:latin typeface="Aptos"/>
-                <a:ea typeface="Aptos"/>
-                <a:cs typeface="Aptos"/>
-              </a:defRPr>
-            </a:lvl2pPr>
-            <a:lvl3pPr algn="ctr">
-              <a:buNone/>
-              <a:defRPr sz="1163" b="1">
-                <a:solidFill>
-                  <a:srgbClr val="A52A2A"/>
-                </a:solidFill>
-                <a:latin typeface="Aptos"/>
-                <a:ea typeface="Aptos"/>
-                <a:cs typeface="Aptos"/>
-              </a:defRPr>
-            </a:lvl3pPr>
-            <a:lvl4pPr algn="ctr">
-              <a:buNone/>
-              <a:defRPr sz="1163" b="1">
-                <a:solidFill>
-                  <a:srgbClr val="A52A2A"/>
-                </a:solidFill>
-                <a:latin typeface="Aptos"/>
-                <a:ea typeface="Aptos"/>
-                <a:cs typeface="Aptos"/>
-              </a:defRPr>
-            </a:lvl4pPr>
-            <a:lvl5pPr algn="ctr">
-              <a:buNone/>
-              <a:defRPr sz="1163" b="1">
-                <a:solidFill>
-                  <a:srgbClr val="A52A2A"/>
-                </a:solidFill>
-                <a:latin typeface="Aptos"/>
-                <a:ea typeface="Aptos"/>
-                <a:cs typeface="Aptos"/>
-              </a:defRPr>
-            </a:lvl5pPr>
-            <a:lvl6pPr algn="ctr">
-              <a:buNone/>
-              <a:defRPr sz="1163" b="1">
-                <a:solidFill>
-                  <a:srgbClr val="A52A2A"/>
-                </a:solidFill>
-                <a:latin typeface="Aptos"/>
-                <a:ea typeface="Aptos"/>
-                <a:cs typeface="Aptos"/>
-              </a:defRPr>
-            </a:lvl6pPr>
-            <a:lvl7pPr algn="ctr">
-              <a:buNone/>
-              <a:defRPr sz="1163" b="1">
-                <a:solidFill>
-                  <a:srgbClr val="A52A2A"/>
-                </a:solidFill>
-                <a:latin typeface="Aptos"/>
-                <a:ea typeface="Aptos"/>
-                <a:cs typeface="Aptos"/>
-              </a:defRPr>
-            </a:lvl7pPr>
-            <a:lvl8pPr algn="ctr">
-              <a:buNone/>
-              <a:defRPr sz="1163" b="1">
-                <a:solidFill>
-                  <a:srgbClr val="A52A2A"/>
-                </a:solidFill>
-                <a:latin typeface="Aptos"/>
-                <a:ea typeface="Aptos"/>
-                <a:cs typeface="Aptos"/>
-              </a:defRPr>
-            </a:lvl8pPr>
-            <a:lvl9pPr algn="ctr">
-              <a:buNone/>
-              <a:defRPr sz="1163" b="1">
-                <a:solidFill>
-                  <a:srgbClr val="A52A2A"/>
-                </a:solidFill>
-                <a:latin typeface="Aptos"/>
-                <a:ea typeface="Aptos"/>
-                <a:cs typeface="Aptos"/>
-              </a:defRPr>
-            </a:lvl9pPr>
-          </a:lstStyle>
-          <a:p>
-            <a:pPr algn="ctr">
-              <a:buNone/>
-              <a:defRPr sz="1163" b="1">
-                <a:solidFill>
-                  <a:srgbClr val="A52A2A"/>
-                </a:solidFill>
-                <a:latin typeface="Aptos"/>
-                <a:ea typeface="Aptos"/>
-                <a:cs typeface="Aptos"/>
-              </a:defRPr>
-            </a:pPr>
-            <a:r>
-              <a:rPr sz="1163" b="1" dirty="0">
-                <a:solidFill>
-                  <a:schemeClr val="tx1"/>
-                </a:solidFill>
-                <a:latin typeface="Times New Roman" panose="02020603050405020304" pitchFamily="18" charset="0"/>
-                <a:cs typeface="Times New Roman" panose="02020603050405020304" pitchFamily="18" charset="0"/>
-              </a:rPr>
-              <a:t>Integrated Fault</a:t>
-            </a:r>
-          </a:p>
-          <a:p>
-            <a:pPr algn="ctr">
-              <a:buNone/>
-              <a:defRPr sz="1163" b="1">
-                <a:solidFill>
-                  <a:srgbClr val="A52A2A"/>
-                </a:solidFill>
-                <a:latin typeface="Aptos"/>
-                <a:ea typeface="Aptos"/>
-                <a:cs typeface="Aptos"/>
-              </a:defRPr>
-            </a:pPr>
-            <a:r>
-              <a:rPr sz="1163" b="1" dirty="0">
-                <a:solidFill>
-                  <a:schemeClr val="tx1"/>
-                </a:solidFill>
-                <a:latin typeface="Times New Roman" panose="02020603050405020304" pitchFamily="18" charset="0"/>
-                <a:cs typeface="Times New Roman" panose="02020603050405020304" pitchFamily="18" charset="0"/>
-              </a:rPr>
-              <a:t>Injection</a:t>
-            </a:r>
-          </a:p>
-        </p:txBody>
-      </p:sp>
-      <p:sp>
-        <p:nvSpPr>
-          <p:cNvPr id="15" name="schematic-callout-3">
-            <a:extLst>
-              <a:ext uri="{FF2B5EF4-FFF2-40B4-BE49-F238E27FC236}">
-                <a16:creationId xmlns:a16="http://schemas.microsoft.com/office/drawing/2014/main" id="{CDF79445-FAB4-6ECE-7840-6F6C4F91FB9C}"/>
-              </a:ext>
-            </a:extLst>
-          </p:cNvPr>
-          <p:cNvSpPr>
-            <a:spLocks noGrp="1"/>
-          </p:cNvSpPr>
-          <p:nvPr/>
-        </p:nvSpPr>
-        <p:spPr>
-          <a:xfrm>
-            <a:off x="5246658" y="5061788"/>
-            <a:ext cx="2133600" cy="409575"/>
-          </a:xfrm>
-          <a:prstGeom prst="rect">
-            <a:avLst/>
-          </a:prstGeom>
-          <a:ln/>
-        </p:spPr>
-        <p:style>
-          <a:lnRef idx="1">
-            <a:schemeClr val="dk1"/>
-          </a:lnRef>
-          <a:fillRef idx="2">
-            <a:schemeClr val="dk1"/>
-          </a:fillRef>
-          <a:effectRef idx="1">
-            <a:schemeClr val="dk1"/>
-          </a:effectRef>
-          <a:fontRef idx="minor">
-            <a:schemeClr val="dk1"/>
-          </a:fontRef>
-        </p:style>
-      </p:sp>
-      <p:sp>
-        <p:nvSpPr>
-          <p:cNvPr id="17" name="schematic-callout-text-3">
-            <a:extLst>
-              <a:ext uri="{FF2B5EF4-FFF2-40B4-BE49-F238E27FC236}">
-                <a16:creationId xmlns:a16="http://schemas.microsoft.com/office/drawing/2014/main" id="{10660CBE-229A-8F24-E372-C5E4F1B13101}"/>
-              </a:ext>
-            </a:extLst>
-          </p:cNvPr>
-          <p:cNvSpPr>
-            <a:spLocks noGrp="1"/>
-          </p:cNvSpPr>
-          <p:nvPr/>
-        </p:nvSpPr>
-        <p:spPr>
-          <a:xfrm>
-            <a:off x="5333611" y="5098974"/>
-            <a:ext cx="2000250" cy="361950"/>
-          </a:xfrm>
-          <a:prstGeom prst="rect">
-            <a:avLst/>
-          </a:prstGeom>
-          <a:noFill/>
-          <a:ln w="0">
-            <a:noFill/>
-            <a:prstDash val="solid"/>
-          </a:ln>
-        </p:spPr>
-        <p:txBody>
-          <a:bodyPr wrap="square" lIns="0" tIns="0" rIns="0" bIns="0" anchor="ctr">
-            <a:normAutofit/>
-          </a:bodyPr>
-          <a:lstStyle>
-            <a:lvl1pPr algn="ctr">
-              <a:buNone/>
-              <a:defRPr sz="1163" b="1">
-                <a:solidFill>
-                  <a:srgbClr val="A52A2A"/>
-                </a:solidFill>
-                <a:latin typeface="Aptos"/>
-                <a:ea typeface="Aptos"/>
-                <a:cs typeface="Aptos"/>
-              </a:defRPr>
-            </a:lvl1pPr>
-            <a:lvl2pPr algn="ctr">
-              <a:buNone/>
-              <a:defRPr sz="1163" b="1">
-                <a:solidFill>
-                  <a:srgbClr val="A52A2A"/>
-                </a:solidFill>
-                <a:latin typeface="Aptos"/>
-                <a:ea typeface="Aptos"/>
-                <a:cs typeface="Aptos"/>
-              </a:defRPr>
-            </a:lvl2pPr>
-            <a:lvl3pPr algn="ctr">
-              <a:buNone/>
-              <a:defRPr sz="1163" b="1">
-                <a:solidFill>
-                  <a:srgbClr val="A52A2A"/>
-                </a:solidFill>
-                <a:latin typeface="Aptos"/>
-                <a:ea typeface="Aptos"/>
-                <a:cs typeface="Aptos"/>
-              </a:defRPr>
-            </a:lvl3pPr>
-            <a:lvl4pPr algn="ctr">
-              <a:buNone/>
-              <a:defRPr sz="1163" b="1">
-                <a:solidFill>
-                  <a:srgbClr val="A52A2A"/>
-                </a:solidFill>
-                <a:latin typeface="Aptos"/>
-                <a:ea typeface="Aptos"/>
-                <a:cs typeface="Aptos"/>
-              </a:defRPr>
-            </a:lvl4pPr>
-            <a:lvl5pPr algn="ctr">
-              <a:buNone/>
-              <a:defRPr sz="1163" b="1">
-                <a:solidFill>
-                  <a:srgbClr val="A52A2A"/>
-                </a:solidFill>
-                <a:latin typeface="Aptos"/>
-                <a:ea typeface="Aptos"/>
-                <a:cs typeface="Aptos"/>
-              </a:defRPr>
-            </a:lvl5pPr>
-            <a:lvl6pPr algn="ctr">
-              <a:buNone/>
-              <a:defRPr sz="1163" b="1">
-                <a:solidFill>
-                  <a:srgbClr val="A52A2A"/>
-                </a:solidFill>
-                <a:latin typeface="Aptos"/>
-                <a:ea typeface="Aptos"/>
-                <a:cs typeface="Aptos"/>
-              </a:defRPr>
-            </a:lvl6pPr>
-            <a:lvl7pPr algn="ctr">
-              <a:buNone/>
-              <a:defRPr sz="1163" b="1">
-                <a:solidFill>
-                  <a:srgbClr val="A52A2A"/>
-                </a:solidFill>
-                <a:latin typeface="Aptos"/>
-                <a:ea typeface="Aptos"/>
-                <a:cs typeface="Aptos"/>
-              </a:defRPr>
-            </a:lvl7pPr>
-            <a:lvl8pPr algn="ctr">
-              <a:buNone/>
-              <a:defRPr sz="1163" b="1">
-                <a:solidFill>
-                  <a:srgbClr val="A52A2A"/>
-                </a:solidFill>
-                <a:latin typeface="Aptos"/>
-                <a:ea typeface="Aptos"/>
-                <a:cs typeface="Aptos"/>
-              </a:defRPr>
-            </a:lvl8pPr>
-            <a:lvl9pPr algn="ctr">
-              <a:buNone/>
-              <a:defRPr sz="1163" b="1">
-                <a:solidFill>
-                  <a:srgbClr val="A52A2A"/>
-                </a:solidFill>
-                <a:latin typeface="Aptos"/>
-                <a:ea typeface="Aptos"/>
-                <a:cs typeface="Aptos"/>
-              </a:defRPr>
-            </a:lvl9pPr>
-          </a:lstStyle>
-          <a:p>
-            <a:pPr algn="ctr">
-              <a:buNone/>
-              <a:defRPr sz="1163" b="1">
-                <a:solidFill>
-                  <a:srgbClr val="A52A2A"/>
-                </a:solidFill>
-                <a:latin typeface="Aptos"/>
-                <a:ea typeface="Aptos"/>
-                <a:cs typeface="Aptos"/>
-              </a:defRPr>
-            </a:pPr>
-            <a:r>
-              <a:rPr sz="1163" b="1" dirty="0">
-                <a:solidFill>
-                  <a:schemeClr val="tx1"/>
-                </a:solidFill>
-                <a:latin typeface="Times New Roman" panose="02020603050405020304" pitchFamily="18" charset="0"/>
-                <a:cs typeface="Times New Roman" panose="02020603050405020304" pitchFamily="18" charset="0"/>
-              </a:rPr>
-              <a:t>RS485 Fleet</a:t>
-            </a:r>
-          </a:p>
-          <a:p>
-            <a:pPr algn="ctr">
-              <a:buNone/>
-              <a:defRPr sz="1163" b="1">
-                <a:solidFill>
-                  <a:srgbClr val="A52A2A"/>
-                </a:solidFill>
-                <a:latin typeface="Aptos"/>
-                <a:ea typeface="Aptos"/>
-                <a:cs typeface="Aptos"/>
-              </a:defRPr>
-            </a:pPr>
-            <a:r>
-              <a:rPr sz="1163" b="1" dirty="0">
-                <a:solidFill>
-                  <a:schemeClr val="tx1"/>
-                </a:solidFill>
-                <a:latin typeface="Times New Roman" panose="02020603050405020304" pitchFamily="18" charset="0"/>
-                <a:cs typeface="Times New Roman" panose="02020603050405020304" pitchFamily="18" charset="0"/>
-              </a:rPr>
-              <a:t>Aggregation</a:t>
-            </a:r>
-          </a:p>
-        </p:txBody>
-      </p:sp>
-      <p:pic>
-        <p:nvPicPr>
-          <p:cNvPr id="19" name="Picture 18">
-            <a:extLst>
-              <a:ext uri="{FF2B5EF4-FFF2-40B4-BE49-F238E27FC236}">
-                <a16:creationId xmlns:a16="http://schemas.microsoft.com/office/drawing/2014/main" id="{2F880241-5445-65C1-75AD-8C4F7B1FD2D9}"/>
-              </a:ext>
-            </a:extLst>
-          </p:cNvPr>
-          <p:cNvPicPr>
-            <a:picLocks noChangeAspect="1"/>
-          </p:cNvPicPr>
-          <p:nvPr/>
-        </p:nvPicPr>
-        <p:blipFill>
-          <a:blip r:embed="rId2">
-            <a:extLst>
-              <a:ext uri="{28A0092B-C50C-407E-A947-70E740481C1C}">
-                <a14:useLocalDpi xmlns:a14="http://schemas.microsoft.com/office/drawing/2010/main" val="0"/>
-              </a:ext>
-            </a:extLst>
-          </a:blip>
-          <a:srcRect t="699" b="1164"/>
-          <a:stretch>
-            <a:fillRect/>
-          </a:stretch>
-        </p:blipFill>
-        <p:spPr>
-          <a:xfrm>
-            <a:off x="182124" y="1216020"/>
-            <a:ext cx="7394812" cy="3702110"/>
-          </a:xfrm>
-          <a:prstGeom prst="rect">
-            <a:avLst/>
-          </a:prstGeom>
-          <a:ln>
-            <a:noFill/>
-          </a:ln>
-          <a:effectLst>
-            <a:outerShdw blurRad="190500" algn="tl" rotWithShape="0">
-              <a:srgbClr val="000000">
-                <a:alpha val="70000"/>
-              </a:srgbClr>
-            </a:outerShdw>
-          </a:effectLst>
-        </p:spPr>
-      </p:pic>
       <p:pic>
         <p:nvPicPr>
           <p:cNvPr id="21" name="Google Shape;270;p21" title="MBF_Logo_2020.png">
@@ -32816,7 +32026,7 @@
           <p:nvPr/>
         </p:nvPicPr>
         <p:blipFill>
-          <a:blip r:embed="rId3">
+          <a:blip r:embed="rId2">
             <a:alphaModFix/>
           </a:blip>
           <a:stretch>
@@ -32850,7 +32060,7 @@
           <p:nvPr/>
         </p:nvPicPr>
         <p:blipFill rotWithShape="1">
-          <a:blip r:embed="rId4">
+          <a:blip r:embed="rId3">
             <a:alphaModFix/>
           </a:blip>
           <a:srcRect l="14673" t="33074" r="15820" b="44466"/>
@@ -32886,7 +32096,7 @@
         </p:nvSpPr>
         <p:spPr>
           <a:xfrm>
-            <a:off x="3041974" y="714783"/>
+            <a:off x="3079296" y="543852"/>
             <a:ext cx="2838061" cy="496141"/>
           </a:xfrm>
           <a:prstGeom prst="rect">
@@ -33520,144 +32730,6 @@
               <a:latin typeface="Times New Roman" panose="02020603050405020304" pitchFamily="18" charset="0"/>
               <a:cs typeface="Times New Roman" panose="02020603050405020304" pitchFamily="18" charset="0"/>
             </a:endParaRPr>
-          </a:p>
-        </p:txBody>
-      </p:sp>
-      <p:sp>
-        <p:nvSpPr>
-          <p:cNvPr id="36" name="Text 5">
-            <a:extLst>
-              <a:ext uri="{FF2B5EF4-FFF2-40B4-BE49-F238E27FC236}">
-                <a16:creationId xmlns:a16="http://schemas.microsoft.com/office/drawing/2014/main" id="{CC3E64CA-C4F5-C60A-6D63-7D4F16B772F4}"/>
-              </a:ext>
-            </a:extLst>
-          </p:cNvPr>
-          <p:cNvSpPr txBox="1"/>
-          <p:nvPr/>
-        </p:nvSpPr>
-        <p:spPr>
-          <a:xfrm>
-            <a:off x="554736" y="6135624"/>
-            <a:ext cx="6199632" cy="137160"/>
-          </a:xfrm>
-          <a:prstGeom prst="rect">
-            <a:avLst/>
-          </a:prstGeom>
-          <a:noFill/>
-          <a:ln/>
-        </p:spPr>
-        <p:txBody>
-          <a:bodyPr wrap="square" lIns="0" tIns="0" rIns="0" bIns="0" rtlCol="0" anchor="ctr">
-            <a:normAutofit/>
-          </a:bodyPr>
-          <a:lstStyle>
-            <a:lvl1pPr marL="0" algn="l" defTabSz="914400" rtl="0" eaLnBrk="1" latinLnBrk="0" hangingPunct="1">
-              <a:defRPr sz="1800" kern="1200">
-                <a:solidFill>
-                  <a:schemeClr val="tx1"/>
-                </a:solidFill>
-                <a:latin typeface="+mn-lt"/>
-                <a:ea typeface="+mn-ea"/>
-                <a:cs typeface="+mn-cs"/>
-              </a:defRPr>
-            </a:lvl1pPr>
-            <a:lvl2pPr marL="457200" algn="l" defTabSz="914400" rtl="0" eaLnBrk="1" latinLnBrk="0" hangingPunct="1">
-              <a:defRPr sz="1800" kern="1200">
-                <a:solidFill>
-                  <a:schemeClr val="tx1"/>
-                </a:solidFill>
-                <a:latin typeface="+mn-lt"/>
-                <a:ea typeface="+mn-ea"/>
-                <a:cs typeface="+mn-cs"/>
-              </a:defRPr>
-            </a:lvl2pPr>
-            <a:lvl3pPr marL="914400" algn="l" defTabSz="914400" rtl="0" eaLnBrk="1" latinLnBrk="0" hangingPunct="1">
-              <a:defRPr sz="1800" kern="1200">
-                <a:solidFill>
-                  <a:schemeClr val="tx1"/>
-                </a:solidFill>
-                <a:latin typeface="+mn-lt"/>
-                <a:ea typeface="+mn-ea"/>
-                <a:cs typeface="+mn-cs"/>
-              </a:defRPr>
-            </a:lvl3pPr>
-            <a:lvl4pPr marL="1371600" algn="l" defTabSz="914400" rtl="0" eaLnBrk="1" latinLnBrk="0" hangingPunct="1">
-              <a:defRPr sz="1800" kern="1200">
-                <a:solidFill>
-                  <a:schemeClr val="tx1"/>
-                </a:solidFill>
-                <a:latin typeface="+mn-lt"/>
-                <a:ea typeface="+mn-ea"/>
-                <a:cs typeface="+mn-cs"/>
-              </a:defRPr>
-            </a:lvl4pPr>
-            <a:lvl5pPr marL="1828800" algn="l" defTabSz="914400" rtl="0" eaLnBrk="1" latinLnBrk="0" hangingPunct="1">
-              <a:defRPr sz="1800" kern="1200">
-                <a:solidFill>
-                  <a:schemeClr val="tx1"/>
-                </a:solidFill>
-                <a:latin typeface="+mn-lt"/>
-                <a:ea typeface="+mn-ea"/>
-                <a:cs typeface="+mn-cs"/>
-              </a:defRPr>
-            </a:lvl5pPr>
-            <a:lvl6pPr marL="2286000" algn="l" defTabSz="914400" rtl="0" eaLnBrk="1" latinLnBrk="0" hangingPunct="1">
-              <a:defRPr sz="1800" kern="1200">
-                <a:solidFill>
-                  <a:schemeClr val="tx1"/>
-                </a:solidFill>
-                <a:latin typeface="+mn-lt"/>
-                <a:ea typeface="+mn-ea"/>
-                <a:cs typeface="+mn-cs"/>
-              </a:defRPr>
-            </a:lvl6pPr>
-            <a:lvl7pPr marL="2743200" algn="l" defTabSz="914400" rtl="0" eaLnBrk="1" latinLnBrk="0" hangingPunct="1">
-              <a:defRPr sz="1800" kern="1200">
-                <a:solidFill>
-                  <a:schemeClr val="tx1"/>
-                </a:solidFill>
-                <a:latin typeface="+mn-lt"/>
-                <a:ea typeface="+mn-ea"/>
-                <a:cs typeface="+mn-cs"/>
-              </a:defRPr>
-            </a:lvl7pPr>
-            <a:lvl8pPr marL="3200400" algn="l" defTabSz="914400" rtl="0" eaLnBrk="1" latinLnBrk="0" hangingPunct="1">
-              <a:defRPr sz="1800" kern="1200">
-                <a:solidFill>
-                  <a:schemeClr val="tx1"/>
-                </a:solidFill>
-                <a:latin typeface="+mn-lt"/>
-                <a:ea typeface="+mn-ea"/>
-                <a:cs typeface="+mn-cs"/>
-              </a:defRPr>
-            </a:lvl8pPr>
-            <a:lvl9pPr marL="3657600" algn="l" defTabSz="914400" rtl="0" eaLnBrk="1" latinLnBrk="0" hangingPunct="1">
-              <a:defRPr sz="1800" kern="1200">
-                <a:solidFill>
-                  <a:schemeClr val="tx1"/>
-                </a:solidFill>
-                <a:latin typeface="+mn-lt"/>
-                <a:ea typeface="+mn-ea"/>
-                <a:cs typeface="+mn-cs"/>
-              </a:defRPr>
-            </a:lvl9pPr>
-          </a:lstStyle>
-          <a:p>
-            <a:pPr marL="0" indent="0" algn="ctr">
-              <a:buNone/>
-            </a:pPr>
-            <a:r>
-              <a:rPr lang="en-US" sz="730" i="1" dirty="0">
-                <a:solidFill>
-                  <a:srgbClr val="69788D"/>
-                </a:solidFill>
-                <a:latin typeface="Aptos" pitchFamily="34" charset="0"/>
-                <a:ea typeface="Aptos" pitchFamily="34" charset="-122"/>
-                <a:cs typeface="Aptos" pitchFamily="34" charset="-120"/>
-              </a:rPr>
-              <a:t>Figure: supplied KiCad schematic • communication, power, I²C, storage, watchdog and fault blocks</a:t>
-            </a:r>
-            <a:endParaRPr lang="en-US" sz="730" dirty="0"/>
           </a:p>
         </p:txBody>
       </p:sp>
@@ -34277,6 +33349,36 @@
           </a:graphicData>
         </a:graphic>
       </p:graphicFrame>
+      <p:pic>
+        <p:nvPicPr>
+          <p:cNvPr id="3" name="Picture 2">
+            <a:extLst>
+              <a:ext uri="{FF2B5EF4-FFF2-40B4-BE49-F238E27FC236}">
+                <a16:creationId xmlns:a16="http://schemas.microsoft.com/office/drawing/2014/main" id="{46E83CB7-28A1-3380-B69A-320BA3DB8609}"/>
+              </a:ext>
+            </a:extLst>
+          </p:cNvPr>
+          <p:cNvPicPr>
+            <a:picLocks noChangeAspect="1"/>
+          </p:cNvPicPr>
+          <p:nvPr/>
+        </p:nvPicPr>
+        <p:blipFill>
+          <a:blip r:embed="rId4"/>
+          <a:stretch>
+            <a:fillRect/>
+          </a:stretch>
+        </p:blipFill>
+        <p:spPr>
+          <a:xfrm>
+            <a:off x="432451" y="910795"/>
+            <a:ext cx="7058051" cy="4770445"/>
+          </a:xfrm>
+          <a:prstGeom prst="rect">
+            <a:avLst/>
+          </a:prstGeom>
+        </p:spPr>
+      </p:pic>
     </p:spTree>
     <p:extLst>
       <p:ext uri="{BB962C8B-B14F-4D97-AF65-F5344CB8AC3E}">

</xml_diff>